<commit_message>
slides + README: the case worker
Co-Authored-By: Claude Fable 5.1 <noreply@anthropic.com>
</commit_message>
<xml_diff>
--- a/slides/haveniq-meeting.pptx
+++ b/slides/haveniq-meeting.pptx
@@ -4870,8 +4870,8 @@
         </p:nvSpPr>
         <p:spPr>
           <a:xfrm>
-            <a:off x="548640" y="4160520"/>
-            <a:ext cx="1828800" cy="1051560"/>
+            <a:off x="548640" y="5440680"/>
+            <a:ext cx="1828800" cy="914400"/>
           </a:xfrm>
           <a:prstGeom prst="roundRect">
             <a:avLst>
@@ -4914,19 +4914,19 @@
                 </a:solidFill>
                 <a:latin typeface="Avenir Next"/>
               </a:rPr>
-              <a:t>Human agent</a:t>
+              <a:t>Case worker agent</a:t>
             </a:r>
           </a:p>
           <a:p>
             <a:pPr algn="ctr"/>
             <a:r>
-              <a:rPr sz="1000">
+              <a:rPr sz="900">
                 <a:solidFill>
                   <a:srgbClr val="626C7A"/>
                 </a:solidFill>
                 <a:latin typeface="Avenir Next"/>
               </a:rPr>
-              <a:t>joins the same room from the desk with the summary</a:t>
+              <a:t>files the call after it ends; answers the team in chat</a:t>
             </a:r>
           </a:p>
         </p:txBody>
@@ -4939,8 +4939,8 @@
         </p:nvCxnSpPr>
         <p:spPr>
           <a:xfrm>
-            <a:off x="2377440" y="2788920"/>
-            <a:ext cx="548640" cy="0"/>
+            <a:off x="2377440" y="5897880"/>
+            <a:ext cx="365760" cy="0"/>
           </a:xfrm>
           <a:prstGeom prst="line">
             <a:avLst/>
@@ -4969,35 +4969,69 @@
       </p:cxnSp>
       <p:sp>
         <p:nvSpPr>
-          <p:cNvPr id="18" name="TextBox 17"/>
-          <p:cNvSpPr txBox="1"/>
-          <p:nvPr/>
-        </p:nvSpPr>
-        <p:spPr>
-          <a:xfrm>
-            <a:off x="1828800" y="2532887"/>
-            <a:ext cx="1645920" cy="274320"/>
-          </a:xfrm>
-          <a:prstGeom prst="rect">
-            <a:avLst/>
-          </a:prstGeom>
-          <a:noFill/>
-        </p:spPr>
-        <p:txBody>
-          <a:bodyPr wrap="square" anchor="t" lIns="0" rIns="0" tIns="0" bIns="0">
-            <a:spAutoFit/>
-          </a:bodyPr>
+          <p:cNvPr id="18" name="Rounded Rectangle 17"/>
+          <p:cNvSpPr/>
+          <p:nvPr/>
+        </p:nvSpPr>
+        <p:spPr>
+          <a:xfrm>
+            <a:off x="548640" y="4160520"/>
+            <a:ext cx="1828800" cy="1051560"/>
+          </a:xfrm>
+          <a:prstGeom prst="roundRect">
+            <a:avLst>
+              <a:gd name="adj" fmla="val 8000"/>
+            </a:avLst>
+          </a:prstGeom>
+          <a:solidFill>
+            <a:srgbClr val="EFF7F5"/>
+          </a:solidFill>
+          <a:ln w="12700">
+            <a:solidFill>
+              <a:srgbClr val="D9DEE6"/>
+            </a:solidFill>
+          </a:ln>
+          <a:effectLst/>
+        </p:spPr>
+        <p:style>
+          <a:lnRef idx="1">
+            <a:schemeClr val="accent1"/>
+          </a:lnRef>
+          <a:fillRef idx="3">
+            <a:schemeClr val="accent1"/>
+          </a:fillRef>
+          <a:effectRef idx="2">
+            <a:schemeClr val="accent1"/>
+          </a:effectRef>
+          <a:fontRef idx="minor">
+            <a:schemeClr val="lt1"/>
+          </a:fontRef>
+        </p:style>
+        <p:txBody>
+          <a:bodyPr rtlCol="0" anchor="ctr" wrap="square" lIns="109728" rIns="109728" tIns="54864" bIns="54864"/>
           <a:lstStyle/>
           <a:p>
             <a:pPr algn="ctr"/>
             <a:r>
-              <a:rPr sz="900" b="0" i="0">
+              <a:rPr sz="1200" b="1">
+                <a:solidFill>
+                  <a:srgbClr val="141C2B"/>
+                </a:solidFill>
+                <a:latin typeface="Avenir Next"/>
+              </a:rPr>
+              <a:t>Human agent</a:t>
+            </a:r>
+          </a:p>
+          <a:p>
+            <a:pPr algn="ctr"/>
+            <a:r>
+              <a:rPr sz="1000">
                 <a:solidFill>
                   <a:srgbClr val="626C7A"/>
                 </a:solidFill>
                 <a:latin typeface="Avenir Next"/>
               </a:rPr>
-              <a:t>audio</a:t>
+              <a:t>joins the same room from the desk with the summary</a:t>
             </a:r>
           </a:p>
         </p:txBody>
@@ -5010,8 +5044,8 @@
         </p:nvCxnSpPr>
         <p:spPr>
           <a:xfrm>
-            <a:off x="4937760" y="2788920"/>
-            <a:ext cx="640080" cy="0"/>
+            <a:off x="2377440" y="2788920"/>
+            <a:ext cx="548640" cy="0"/>
           </a:xfrm>
           <a:prstGeom prst="line">
             <a:avLst/>
@@ -5046,7 +5080,7 @@
         </p:nvSpPr>
         <p:spPr>
           <a:xfrm>
-            <a:off x="4434840" y="2532887"/>
+            <a:off x="1828800" y="2532887"/>
             <a:ext cx="1645920" cy="274320"/>
           </a:xfrm>
           <a:prstGeom prst="rect">
@@ -5068,7 +5102,7 @@
                 </a:solidFill>
                 <a:latin typeface="Avenir Next"/>
               </a:rPr>
-              <a:t>dispatch</a:t>
+              <a:t>audio</a:t>
             </a:r>
           </a:p>
         </p:txBody>
@@ -5081,8 +5115,8 @@
         </p:nvCxnSpPr>
         <p:spPr>
           <a:xfrm>
-            <a:off x="7955279" y="2788920"/>
-            <a:ext cx="640081" cy="0"/>
+            <a:off x="4937760" y="2788920"/>
+            <a:ext cx="640080" cy="0"/>
           </a:xfrm>
           <a:prstGeom prst="line">
             <a:avLst/>
@@ -5117,7 +5151,7 @@
         </p:nvSpPr>
         <p:spPr>
           <a:xfrm>
-            <a:off x="7452360" y="2532887"/>
+            <a:off x="4434840" y="2532887"/>
             <a:ext cx="1645920" cy="274320"/>
           </a:xfrm>
           <a:prstGeom prst="rect">
@@ -5139,7 +5173,7 @@
                 </a:solidFill>
                 <a:latin typeface="Avenir Next"/>
               </a:rPr>
-              <a:t>turns</a:t>
+              <a:t>dispatch</a:t>
             </a:r>
           </a:p>
         </p:txBody>
@@ -5152,8 +5186,8 @@
         </p:nvCxnSpPr>
         <p:spPr>
           <a:xfrm>
-            <a:off x="6766560" y="3566160"/>
-            <a:ext cx="0" cy="594360"/>
+            <a:off x="7955279" y="2788920"/>
+            <a:ext cx="640081" cy="0"/>
           </a:xfrm>
           <a:prstGeom prst="line">
             <a:avLst/>
@@ -5188,7 +5222,7 @@
         </p:nvSpPr>
         <p:spPr>
           <a:xfrm>
-            <a:off x="5943600" y="3607307"/>
+            <a:off x="7452360" y="2532887"/>
             <a:ext cx="1645920" cy="274320"/>
           </a:xfrm>
           <a:prstGeom prst="rect">
@@ -5210,7 +5244,7 @@
                 </a:solidFill>
                 <a:latin typeface="Avenir Next"/>
               </a:rPr>
-              <a:t>tool calls</a:t>
+              <a:t>turns</a:t>
             </a:r>
           </a:p>
         </p:txBody>
@@ -5218,6 +5252,77 @@
       <p:cxnSp>
         <p:nvCxnSpPr>
           <p:cNvPr id="25" name="Connector 24"/>
+          <p:cNvCxnSpPr/>
+          <p:nvPr/>
+        </p:nvCxnSpPr>
+        <p:spPr>
+          <a:xfrm>
+            <a:off x="6766560" y="3566160"/>
+            <a:ext cx="0" cy="594360"/>
+          </a:xfrm>
+          <a:prstGeom prst="line">
+            <a:avLst/>
+          </a:prstGeom>
+          <a:ln w="19050">
+            <a:solidFill>
+              <a:srgbClr val="626C7A"/>
+            </a:solidFill>
+            <a:tailEnd type="triangle"/>
+          </a:ln>
+        </p:spPr>
+        <p:style>
+          <a:lnRef idx="2">
+            <a:schemeClr val="accent1"/>
+          </a:lnRef>
+          <a:fillRef idx="0">
+            <a:schemeClr val="accent1"/>
+          </a:fillRef>
+          <a:effectRef idx="1">
+            <a:schemeClr val="accent1"/>
+          </a:effectRef>
+          <a:fontRef idx="minor">
+            <a:schemeClr val="tx1"/>
+          </a:fontRef>
+        </p:style>
+      </p:cxnSp>
+      <p:sp>
+        <p:nvSpPr>
+          <p:cNvPr id="26" name="TextBox 25"/>
+          <p:cNvSpPr txBox="1"/>
+          <p:nvPr/>
+        </p:nvSpPr>
+        <p:spPr>
+          <a:xfrm>
+            <a:off x="5943600" y="3607307"/>
+            <a:ext cx="1645920" cy="274320"/>
+          </a:xfrm>
+          <a:prstGeom prst="rect">
+            <a:avLst/>
+          </a:prstGeom>
+          <a:noFill/>
+        </p:spPr>
+        <p:txBody>
+          <a:bodyPr wrap="square" anchor="t" lIns="0" rIns="0" tIns="0" bIns="0">
+            <a:spAutoFit/>
+          </a:bodyPr>
+          <a:lstStyle/>
+          <a:p>
+            <a:pPr algn="ctr"/>
+            <a:r>
+              <a:rPr sz="900" b="0" i="0">
+                <a:solidFill>
+                  <a:srgbClr val="626C7A"/>
+                </a:solidFill>
+                <a:latin typeface="Avenir Next"/>
+              </a:rPr>
+              <a:t>tool calls</a:t>
+            </a:r>
+          </a:p>
+        </p:txBody>
+      </p:sp>
+      <p:cxnSp>
+        <p:nvCxnSpPr>
+          <p:cNvPr id="27" name="Connector 26"/>
           <p:cNvCxnSpPr/>
           <p:nvPr/>
         </p:nvCxnSpPr>
@@ -5253,7 +5358,7 @@
       </p:cxnSp>
       <p:cxnSp>
         <p:nvCxnSpPr>
-          <p:cNvPr id="26" name="Connector 25"/>
+          <p:cNvPr id="28" name="Connector 27"/>
           <p:cNvCxnSpPr/>
           <p:nvPr/>
         </p:nvCxnSpPr>
@@ -5289,7 +5394,7 @@
       </p:cxnSp>
       <p:cxnSp>
         <p:nvCxnSpPr>
-          <p:cNvPr id="27" name="Connector 26"/>
+          <p:cNvPr id="29" name="Connector 28"/>
           <p:cNvCxnSpPr/>
           <p:nvPr/>
         </p:nvCxnSpPr>
@@ -5325,7 +5430,7 @@
       </p:cxnSp>
       <p:sp>
         <p:nvSpPr>
-          <p:cNvPr id="28" name="TextBox 27"/>
+          <p:cNvPr id="30" name="TextBox 29"/>
           <p:cNvSpPr txBox="1"/>
           <p:nvPr/>
         </p:nvSpPr>
@@ -5360,7 +5465,7 @@
       </p:sp>
       <p:cxnSp>
         <p:nvCxnSpPr>
-          <p:cNvPr id="29" name="Connector 28"/>
+          <p:cNvPr id="31" name="Connector 30"/>
           <p:cNvCxnSpPr/>
           <p:nvPr/>
         </p:nvCxnSpPr>
@@ -5396,7 +5501,7 @@
       </p:cxnSp>
       <p:sp>
         <p:nvSpPr>
-          <p:cNvPr id="30" name="TextBox 29"/>
+          <p:cNvPr id="32" name="TextBox 31"/>
           <p:cNvSpPr txBox="1"/>
           <p:nvPr/>
         </p:nvSpPr>
@@ -5431,7 +5536,7 @@
       </p:sp>
       <p:cxnSp>
         <p:nvCxnSpPr>
-          <p:cNvPr id="31" name="Connector 30"/>
+          <p:cNvPr id="33" name="Connector 32"/>
           <p:cNvCxnSpPr/>
           <p:nvPr/>
         </p:nvCxnSpPr>
@@ -5467,7 +5572,7 @@
       </p:cxnSp>
       <p:sp>
         <p:nvSpPr>
-          <p:cNvPr id="32" name="TextBox 31"/>
+          <p:cNvPr id="34" name="TextBox 33"/>
           <p:cNvSpPr txBox="1"/>
           <p:nvPr/>
         </p:nvSpPr>
@@ -5986,7 +6091,7 @@
                 </a:solidFill>
                 <a:latin typeface="Avenir Next"/>
               </a:rPr>
-              <a:t>The recording lands in HavenIQ's own object store and is attached to the ticket, so the follow-up has both the summary and the audio.</a:t>
+              <a:t>The recording lands in HavenIQ's own object store and is attached to the ticket, and a second agent, the case worker, files the call: category, facts, follow-ups.</a:t>
             </a:r>
           </a:p>
         </p:txBody>

</xml_diff>